<commit_message>
Fix the slide decks so PowerPoint can open them
The generated .pptx would not open. Two causes:

- The package was rebuilt from a hand-made skeleton, including a
  docProps/app.xml whose elements were in the wrong order. Office
  validates that part strictly. The decks now reuse the existing
  package from the topic 1 bundle untouched and only replace the ten
  slide bodies, so docProps, presentation.xml and the masters stay
  byte-identical to a file that already worked.
- Section headings containing "&" went into the slide name attribute
  unescaped, leaving two slides with malformed XML.

Also drop the content-type overrides that pointed at slide masters the
package never contained.

Co-Authored-By: Claude Opus 5 <noreply@anthropic.com>
</commit_message>
<xml_diff>
--- a/goc-hoc-tap/bai-hoc-gddp11/cd1-nd3-du-lich-xanh.pptx
+++ b/goc-hoc-tap/bai-hoc-gddp11/cd1-nd3-du-lich-xanh.pptx
@@ -1,6 +1,6 @@
 
 <file path=ppt/presentation.xml><?xml version="1.0" encoding="utf-8"?>
-<p:presentation xmlns:a="http://schemas.openxmlformats.org/drawingml/2006/main" xmlns:r="http://schemas.openxmlformats.org/officeDocument/2006/relationships" xmlns:p="http://schemas.openxmlformats.org/presentationml/2006/main" saveSubsetFonts="1">
+<p:presentation xmlns:a="http://schemas.openxmlformats.org/drawingml/2006/main" xmlns:r="http://schemas.openxmlformats.org/officeDocument/2006/relationships" xmlns:p="http://schemas.openxmlformats.org/presentationml/2006/main" saveSubsetFonts="1" autoCompressPictures="0">
   <p:sldMasterIdLst>
     <p:sldMasterId id="2147483648" r:id="rId1"/>
   </p:sldMasterIdLst>
@@ -16,14 +16,1333 @@
     <p:sldId id="264" r:id="rId10"/>
     <p:sldId id="265" r:id="rId11"/>
   </p:sldIdLst>
+  <p:notesMasterIdLst>
+    <p:notesMasterId r:id="rId12"/>
+  </p:notesMasterIdLst>
   <p:sldSz cx="12192000" cy="6858000"/>
-  <p:notesSz cx="6858000" cy="9144000"/>
+  <p:notesSz cx="6858000" cy="12192000"/>
   <p:defaultTextStyle>
-    <a:defPPr>
-      <a:defRPr lang="vi-VN"/>
-    </a:defPPr>
+    <a:lvl1pPr marL="0" algn="l" defTabSz="914400" rtl="0" eaLnBrk="1" latinLnBrk="0" hangingPunct="1">
+      <a:defRPr sz="1800" kern="1200">
+        <a:solidFill>
+          <a:schemeClr val="tx1"/>
+        </a:solidFill>
+        <a:latin typeface="+mn-lt"/>
+        <a:ea typeface="+mn-ea"/>
+        <a:cs typeface="+mn-cs"/>
+      </a:defRPr>
+    </a:lvl1pPr>
+    <a:lvl2pPr marL="457200" algn="l" defTabSz="914400" rtl="0" eaLnBrk="1" latinLnBrk="0" hangingPunct="1">
+      <a:defRPr sz="1800" kern="1200">
+        <a:solidFill>
+          <a:schemeClr val="tx1"/>
+        </a:solidFill>
+        <a:latin typeface="+mn-lt"/>
+        <a:ea typeface="+mn-ea"/>
+        <a:cs typeface="+mn-cs"/>
+      </a:defRPr>
+    </a:lvl2pPr>
+    <a:lvl3pPr marL="914400" algn="l" defTabSz="914400" rtl="0" eaLnBrk="1" latinLnBrk="0" hangingPunct="1">
+      <a:defRPr sz="1800" kern="1200">
+        <a:solidFill>
+          <a:schemeClr val="tx1"/>
+        </a:solidFill>
+        <a:latin typeface="+mn-lt"/>
+        <a:ea typeface="+mn-ea"/>
+        <a:cs typeface="+mn-cs"/>
+      </a:defRPr>
+    </a:lvl3pPr>
+    <a:lvl4pPr marL="1371600" algn="l" defTabSz="914400" rtl="0" eaLnBrk="1" latinLnBrk="0" hangingPunct="1">
+      <a:defRPr sz="1800" kern="1200">
+        <a:solidFill>
+          <a:schemeClr val="tx1"/>
+        </a:solidFill>
+        <a:latin typeface="+mn-lt"/>
+        <a:ea typeface="+mn-ea"/>
+        <a:cs typeface="+mn-cs"/>
+      </a:defRPr>
+    </a:lvl4pPr>
+    <a:lvl5pPr marL="1828800" algn="l" defTabSz="914400" rtl="0" eaLnBrk="1" latinLnBrk="0" hangingPunct="1">
+      <a:defRPr sz="1800" kern="1200">
+        <a:solidFill>
+          <a:schemeClr val="tx1"/>
+        </a:solidFill>
+        <a:latin typeface="+mn-lt"/>
+        <a:ea typeface="+mn-ea"/>
+        <a:cs typeface="+mn-cs"/>
+      </a:defRPr>
+    </a:lvl5pPr>
+    <a:lvl6pPr marL="2286000" algn="l" defTabSz="914400" rtl="0" eaLnBrk="1" latinLnBrk="0" hangingPunct="1">
+      <a:defRPr sz="1800" kern="1200">
+        <a:solidFill>
+          <a:schemeClr val="tx1"/>
+        </a:solidFill>
+        <a:latin typeface="+mn-lt"/>
+        <a:ea typeface="+mn-ea"/>
+        <a:cs typeface="+mn-cs"/>
+      </a:defRPr>
+    </a:lvl6pPr>
+    <a:lvl7pPr marL="2743200" algn="l" defTabSz="914400" rtl="0" eaLnBrk="1" latinLnBrk="0" hangingPunct="1">
+      <a:defRPr sz="1800" kern="1200">
+        <a:solidFill>
+          <a:schemeClr val="tx1"/>
+        </a:solidFill>
+        <a:latin typeface="+mn-lt"/>
+        <a:ea typeface="+mn-ea"/>
+        <a:cs typeface="+mn-cs"/>
+      </a:defRPr>
+    </a:lvl7pPr>
+    <a:lvl8pPr marL="3200400" algn="l" defTabSz="914400" rtl="0" eaLnBrk="1" latinLnBrk="0" hangingPunct="1">
+      <a:defRPr sz="1800" kern="1200">
+        <a:solidFill>
+          <a:schemeClr val="tx1"/>
+        </a:solidFill>
+        <a:latin typeface="+mn-lt"/>
+        <a:ea typeface="+mn-ea"/>
+        <a:cs typeface="+mn-cs"/>
+      </a:defRPr>
+    </a:lvl8pPr>
+    <a:lvl9pPr marL="3657600" algn="l" defTabSz="914400" rtl="0" eaLnBrk="1" latinLnBrk="0" hangingPunct="1">
+      <a:defRPr sz="1800" kern="1200">
+        <a:solidFill>
+          <a:schemeClr val="tx1"/>
+        </a:solidFill>
+        <a:latin typeface="+mn-lt"/>
+        <a:ea typeface="+mn-ea"/>
+        <a:cs typeface="+mn-cs"/>
+      </a:defRPr>
+    </a:lvl9pPr>
   </p:defaultTextStyle>
 </p:presentation>
+</file>
+
+<file path=ppt/notesMasters/notesMaster1.xml><?xml version="1.0" encoding="utf-8"?>
+<p:notesMaster xmlns:a="http://schemas.openxmlformats.org/drawingml/2006/main" xmlns:r="http://schemas.openxmlformats.org/officeDocument/2006/relationships" xmlns:p="http://schemas.openxmlformats.org/presentationml/2006/main">
+  <p:cSld>
+    <p:bg>
+      <p:bgRef idx="1001">
+        <a:schemeClr val="bg1"/>
+      </p:bgRef>
+    </p:bg>
+    <p:spTree>
+      <p:nvGrpSpPr>
+        <p:cNvPr id="1" name=""/>
+        <p:cNvGrpSpPr/>
+        <p:nvPr/>
+      </p:nvGrpSpPr>
+      <p:grpSpPr>
+        <a:xfrm>
+          <a:off x="0" y="0"/>
+          <a:ext cx="0" cy="0"/>
+          <a:chOff x="0" y="0"/>
+          <a:chExt cx="0" cy="0"/>
+        </a:xfrm>
+      </p:grpSpPr>
+      <p:sp>
+        <p:nvSpPr>
+          <p:cNvPr id="2" name="Header Placeholder 1"/>
+          <p:cNvSpPr>
+            <a:spLocks noGrp="1"/>
+          </p:cNvSpPr>
+          <p:nvPr>
+            <p:ph type="hdr" sz="quarter"/>
+          </p:nvPr>
+        </p:nvSpPr>
+        <p:spPr>
+          <a:xfrm>
+            <a:off x="0" y="0"/>
+            <a:ext cx="2971800" cy="458788"/>
+          </a:xfrm>
+          <a:prstGeom prst="rect">
+            <a:avLst/>
+          </a:prstGeom>
+        </p:spPr>
+        <p:txBody>
+          <a:bodyPr vert="horz" lIns="91440" tIns="45720" rIns="91440" bIns="45720" rtlCol="0"/>
+          <a:lstStyle>
+            <a:lvl1pPr algn="l">
+              <a:defRPr sz="1200"/>
+            </a:lvl1pPr>
+          </a:lstStyle>
+          <a:p>
+            <a:endParaRPr lang="en-US"/>
+          </a:p>
+        </p:txBody>
+      </p:sp>
+      <p:sp>
+        <p:nvSpPr>
+          <p:cNvPr id="3" name="Date Placeholder 2"/>
+          <p:cNvSpPr>
+            <a:spLocks noGrp="1"/>
+          </p:cNvSpPr>
+          <p:nvPr>
+            <p:ph type="dt" idx="1"/>
+          </p:nvPr>
+        </p:nvSpPr>
+        <p:spPr>
+          <a:xfrm>
+            <a:off x="3884613" y="0"/>
+            <a:ext cx="2971800" cy="458788"/>
+          </a:xfrm>
+          <a:prstGeom prst="rect">
+            <a:avLst/>
+          </a:prstGeom>
+        </p:spPr>
+        <p:txBody>
+          <a:bodyPr vert="horz" lIns="91440" tIns="45720" rIns="91440" bIns="45720" rtlCol="0"/>
+          <a:lstStyle>
+            <a:lvl1pPr algn="r">
+              <a:defRPr sz="1200"/>
+            </a:lvl1pPr>
+          </a:lstStyle>
+          <a:p>
+            <a:fld id="{5282F153-3F37-0F45-9E97-73ACFA13230C}" type="datetimeFigureOut">
+              <a:rPr lang="en-US"/>
+              <a:t>7/23/19</a:t>
+            </a:fld>
+            <a:endParaRPr lang="en-US"/>
+          </a:p>
+        </p:txBody>
+      </p:sp>
+      <p:sp>
+        <p:nvSpPr>
+          <p:cNvPr id="4" name="Slide Image Placeholder 3"/>
+          <p:cNvSpPr>
+            <a:spLocks noGrp="1" noRot="1" noChangeAspect="1"/>
+          </p:cNvSpPr>
+          <p:nvPr>
+            <p:ph type="sldImg" idx="2"/>
+          </p:nvPr>
+        </p:nvSpPr>
+        <p:spPr>
+          <a:xfrm>
+            <a:off x="685800" y="1143000"/>
+            <a:ext cx="5486400" cy="3086100"/>
+          </a:xfrm>
+          <a:prstGeom prst="rect">
+            <a:avLst/>
+          </a:prstGeom>
+          <a:noFill/>
+          <a:ln w="12700">
+            <a:solidFill>
+              <a:prstClr val="black"/>
+            </a:solidFill>
+          </a:ln>
+        </p:spPr>
+        <p:txBody>
+          <a:bodyPr vert="horz" lIns="91440" tIns="45720" rIns="91440" bIns="45720" rtlCol="0" anchor="ctr"/>
+          <a:lstStyle/>
+          <a:p>
+            <a:endParaRPr lang="en-US"/>
+          </a:p>
+        </p:txBody>
+      </p:sp>
+      <p:sp>
+        <p:nvSpPr>
+          <p:cNvPr id="5" name="Notes Placeholder 4"/>
+          <p:cNvSpPr>
+            <a:spLocks noGrp="1"/>
+          </p:cNvSpPr>
+          <p:nvPr>
+            <p:ph type="body" sz="quarter" idx="3"/>
+          </p:nvPr>
+        </p:nvSpPr>
+        <p:spPr>
+          <a:xfrm>
+            <a:off x="685800" y="4400550"/>
+            <a:ext cx="5486400" cy="3600450"/>
+          </a:xfrm>
+          <a:prstGeom prst="rect">
+            <a:avLst/>
+          </a:prstGeom>
+        </p:spPr>
+        <p:txBody>
+          <a:bodyPr vert="horz" lIns="91440" tIns="45720" rIns="91440" bIns="45720" rtlCol="0"/>
+          <a:lstStyle/>
+          <a:p>
+            <a:pPr lvl="0"/>
+            <a:r>
+              <a:rPr lang="en-US"/>
+              <a:t>Click to edit Master text styles</a:t>
+            </a:r>
+          </a:p>
+          <a:p>
+            <a:pPr lvl="1"/>
+            <a:r>
+              <a:rPr lang="en-US"/>
+              <a:t>Second level</a:t>
+            </a:r>
+          </a:p>
+          <a:p>
+            <a:pPr lvl="2"/>
+            <a:r>
+              <a:rPr lang="en-US"/>
+              <a:t>Third level</a:t>
+            </a:r>
+          </a:p>
+          <a:p>
+            <a:pPr lvl="3"/>
+            <a:r>
+              <a:rPr lang="en-US"/>
+              <a:t>Fourth level</a:t>
+            </a:r>
+          </a:p>
+          <a:p>
+            <a:pPr lvl="4"/>
+            <a:r>
+              <a:rPr lang="en-US"/>
+              <a:t>Fifth level</a:t>
+            </a:r>
+          </a:p>
+        </p:txBody>
+      </p:sp>
+      <p:sp>
+        <p:nvSpPr>
+          <p:cNvPr id="6" name="Footer Placeholder 5"/>
+          <p:cNvSpPr>
+            <a:spLocks noGrp="1"/>
+          </p:cNvSpPr>
+          <p:nvPr>
+            <p:ph type="ftr" sz="quarter" idx="4"/>
+          </p:nvPr>
+        </p:nvSpPr>
+        <p:spPr>
+          <a:xfrm>
+            <a:off x="0" y="8685213"/>
+            <a:ext cx="2971800" cy="458787"/>
+          </a:xfrm>
+          <a:prstGeom prst="rect">
+            <a:avLst/>
+          </a:prstGeom>
+        </p:spPr>
+        <p:txBody>
+          <a:bodyPr vert="horz" lIns="91440" tIns="45720" rIns="91440" bIns="45720" rtlCol="0" anchor="b"/>
+          <a:lstStyle>
+            <a:lvl1pPr algn="l">
+              <a:defRPr sz="1200"/>
+            </a:lvl1pPr>
+          </a:lstStyle>
+          <a:p>
+            <a:endParaRPr lang="en-US"/>
+          </a:p>
+        </p:txBody>
+      </p:sp>
+      <p:sp>
+        <p:nvSpPr>
+          <p:cNvPr id="7" name="Slide Number Placeholder 6"/>
+          <p:cNvSpPr>
+            <a:spLocks noGrp="1"/>
+          </p:cNvSpPr>
+          <p:nvPr>
+            <p:ph type="sldNum" sz="quarter" idx="5"/>
+          </p:nvPr>
+        </p:nvSpPr>
+        <p:spPr>
+          <a:xfrm>
+            <a:off x="3884613" y="8685213"/>
+            <a:ext cx="2971800" cy="458787"/>
+          </a:xfrm>
+          <a:prstGeom prst="rect">
+            <a:avLst/>
+          </a:prstGeom>
+        </p:spPr>
+        <p:txBody>
+          <a:bodyPr vert="horz" lIns="91440" tIns="45720" rIns="91440" bIns="45720" rtlCol="0" anchor="b"/>
+          <a:lstStyle>
+            <a:lvl1pPr algn="r">
+              <a:defRPr sz="1200"/>
+            </a:lvl1pPr>
+          </a:lstStyle>
+          <a:p>
+            <a:fld id="{CE5E9CC1-C706-0F49-92D6-E571CC5EEA8F}" type="slidenum">
+              <a:rPr lang="en-US"/>
+              <a:t>‹#›</a:t>
+            </a:fld>
+            <a:endParaRPr lang="en-US"/>
+          </a:p>
+        </p:txBody>
+      </p:sp>
+    </p:spTree>
+    <p:extLst>
+      <p:ext uri="{BB962C8B-B14F-4D97-AF65-F5344CB8AC3E}">
+        <p14:creationId xmlns:p14="http://schemas.microsoft.com/office/powerpoint/2010/main" val="1024086991"/>
+      </p:ext>
+    </p:extLst>
+  </p:cSld>
+  <p:clrMap bg1="lt1" tx1="dk1" bg2="lt2" tx2="dk2" accent1="accent1" accent2="accent2" accent3="accent3" accent4="accent4" accent5="accent5" accent6="accent6" hlink="hlink" folHlink="folHlink"/>
+  <p:notesStyle>
+    <a:lvl1pPr marL="0" algn="l" defTabSz="914400" rtl="0" eaLnBrk="1" latinLnBrk="0" hangingPunct="1">
+      <a:defRPr sz="1200" kern="1200">
+        <a:solidFill>
+          <a:schemeClr val="tx1"/>
+        </a:solidFill>
+        <a:latin typeface="+mn-lt"/>
+        <a:ea typeface="+mn-ea"/>
+        <a:cs typeface="+mn-cs"/>
+      </a:defRPr>
+    </a:lvl1pPr>
+    <a:lvl2pPr marL="457200" algn="l" defTabSz="914400" rtl="0" eaLnBrk="1" latinLnBrk="0" hangingPunct="1">
+      <a:defRPr sz="1200" kern="1200">
+        <a:solidFill>
+          <a:schemeClr val="tx1"/>
+        </a:solidFill>
+        <a:latin typeface="+mn-lt"/>
+        <a:ea typeface="+mn-ea"/>
+        <a:cs typeface="+mn-cs"/>
+      </a:defRPr>
+    </a:lvl2pPr>
+    <a:lvl3pPr marL="914400" algn="l" defTabSz="914400" rtl="0" eaLnBrk="1" latinLnBrk="0" hangingPunct="1">
+      <a:defRPr sz="1200" kern="1200">
+        <a:solidFill>
+          <a:schemeClr val="tx1"/>
+        </a:solidFill>
+        <a:latin typeface="+mn-lt"/>
+        <a:ea typeface="+mn-ea"/>
+        <a:cs typeface="+mn-cs"/>
+      </a:defRPr>
+    </a:lvl3pPr>
+    <a:lvl4pPr marL="1371600" algn="l" defTabSz="914400" rtl="0" eaLnBrk="1" latinLnBrk="0" hangingPunct="1">
+      <a:defRPr sz="1200" kern="1200">
+        <a:solidFill>
+          <a:schemeClr val="tx1"/>
+        </a:solidFill>
+        <a:latin typeface="+mn-lt"/>
+        <a:ea typeface="+mn-ea"/>
+        <a:cs typeface="+mn-cs"/>
+      </a:defRPr>
+    </a:lvl4pPr>
+    <a:lvl5pPr marL="1828800" algn="l" defTabSz="914400" rtl="0" eaLnBrk="1" latinLnBrk="0" hangingPunct="1">
+      <a:defRPr sz="1200" kern="1200">
+        <a:solidFill>
+          <a:schemeClr val="tx1"/>
+        </a:solidFill>
+        <a:latin typeface="+mn-lt"/>
+        <a:ea typeface="+mn-ea"/>
+        <a:cs typeface="+mn-cs"/>
+      </a:defRPr>
+    </a:lvl5pPr>
+    <a:lvl6pPr marL="2286000" algn="l" defTabSz="914400" rtl="0" eaLnBrk="1" latinLnBrk="0" hangingPunct="1">
+      <a:defRPr sz="1200" kern="1200">
+        <a:solidFill>
+          <a:schemeClr val="tx1"/>
+        </a:solidFill>
+        <a:latin typeface="+mn-lt"/>
+        <a:ea typeface="+mn-ea"/>
+        <a:cs typeface="+mn-cs"/>
+      </a:defRPr>
+    </a:lvl6pPr>
+    <a:lvl7pPr marL="2743200" algn="l" defTabSz="914400" rtl="0" eaLnBrk="1" latinLnBrk="0" hangingPunct="1">
+      <a:defRPr sz="1200" kern="1200">
+        <a:solidFill>
+          <a:schemeClr val="tx1"/>
+        </a:solidFill>
+        <a:latin typeface="+mn-lt"/>
+        <a:ea typeface="+mn-ea"/>
+        <a:cs typeface="+mn-cs"/>
+      </a:defRPr>
+    </a:lvl7pPr>
+    <a:lvl8pPr marL="3200400" algn="l" defTabSz="914400" rtl="0" eaLnBrk="1" latinLnBrk="0" hangingPunct="1">
+      <a:defRPr sz="1200" kern="1200">
+        <a:solidFill>
+          <a:schemeClr val="tx1"/>
+        </a:solidFill>
+        <a:latin typeface="+mn-lt"/>
+        <a:ea typeface="+mn-ea"/>
+        <a:cs typeface="+mn-cs"/>
+      </a:defRPr>
+    </a:lvl8pPr>
+    <a:lvl9pPr marL="3657600" algn="l" defTabSz="914400" rtl="0" eaLnBrk="1" latinLnBrk="0" hangingPunct="1">
+      <a:defRPr sz="1200" kern="1200">
+        <a:solidFill>
+          <a:schemeClr val="tx1"/>
+        </a:solidFill>
+        <a:latin typeface="+mn-lt"/>
+        <a:ea typeface="+mn-ea"/>
+        <a:cs typeface="+mn-cs"/>
+      </a:defRPr>
+    </a:lvl9pPr>
+  </p:notesStyle>
+</p:notesMaster>
+</file>
+
+<file path=ppt/notesSlides/notesSlide1.xml><?xml version="1.0" encoding="utf-8"?>
+<p:notes xmlns:a="http://schemas.openxmlformats.org/drawingml/2006/main" xmlns:r="http://schemas.openxmlformats.org/officeDocument/2006/relationships" xmlns:p="http://schemas.openxmlformats.org/presentationml/2006/main">
+  <p:cSld>
+    <p:spTree>
+      <p:nvGrpSpPr>
+        <p:cNvPr id="1" name=""/>
+        <p:cNvGrpSpPr/>
+        <p:nvPr/>
+      </p:nvGrpSpPr>
+      <p:grpSpPr>
+        <a:xfrm>
+          <a:off x="0" y="0"/>
+          <a:ext cx="0" cy="0"/>
+          <a:chOff x="0" y="0"/>
+          <a:chExt cx="0" cy="0"/>
+        </a:xfrm>
+      </p:grpSpPr>
+      <p:sp>
+        <p:nvSpPr>
+          <p:cNvPr id="2" name="Slide Image Placeholder 1"/>
+          <p:cNvSpPr>
+            <a:spLocks noGrp="1" noRot="1" noChangeAspect="1"/>
+          </p:cNvSpPr>
+          <p:nvPr>
+            <p:ph type="sldImg"/>
+          </p:nvPr>
+        </p:nvSpPr>
+        <p:spPr/>
+      </p:sp>
+      <p:sp>
+        <p:nvSpPr>
+          <p:cNvPr id="3" name="Notes Placeholder 2"/>
+          <p:cNvSpPr>
+            <a:spLocks noGrp="1"/>
+          </p:cNvSpPr>
+          <p:nvPr>
+            <p:ph type="body" idx="1"/>
+          </p:nvPr>
+        </p:nvSpPr>
+        <p:spPr/>
+        <p:txBody>
+          <a:bodyPr/>
+          <a:lstStyle/>
+          <a:p>
+            <a:r>
+              <a:rPr lang="en-US" dirty="0"/>
+              <a:t/>
+            </a:r>
+            <a:endParaRPr lang="en-US" dirty="0"/>
+          </a:p>
+        </p:txBody>
+      </p:sp>
+      <p:sp>
+        <p:nvSpPr>
+          <p:cNvPr id="4" name="Slide Number Placeholder 3"/>
+          <p:cNvSpPr>
+            <a:spLocks noGrp="1"/>
+          </p:cNvSpPr>
+          <p:nvPr>
+            <p:ph type="sldNum" sz="quarter" idx="10"/>
+          </p:nvPr>
+        </p:nvSpPr>
+        <p:spPr/>
+        <p:txBody>
+          <a:bodyPr/>
+          <a:lstStyle/>
+          <a:p>
+            <a:fld id="{F7021451-1387-4CA6-816F-3879F97B5CBC}" type="slidenum">
+              <a:rPr lang="en-US"/>
+              <a:t>1</a:t>
+            </a:fld>
+            <a:endParaRPr lang="en-US"/>
+          </a:p>
+        </p:txBody>
+      </p:sp>
+    </p:spTree>
+    <p:extLst>
+      <p:ext uri="{BB962C8B-B14F-4D97-AF65-F5344CB8AC3E}">
+        <p14:creationId xmlns:p14="http://schemas.microsoft.com/office/powerpoint/2010/main" val="1024086991"/>
+      </p:ext>
+    </p:extLst>
+  </p:cSld>
+  <p:clrMapOvr>
+    <a:masterClrMapping/>
+  </p:clrMapOvr>
+</p:notes>
+</file>
+
+<file path=ppt/notesSlides/notesSlide10.xml><?xml version="1.0" encoding="utf-8"?>
+<p:notes xmlns:a="http://schemas.openxmlformats.org/drawingml/2006/main" xmlns:r="http://schemas.openxmlformats.org/officeDocument/2006/relationships" xmlns:p="http://schemas.openxmlformats.org/presentationml/2006/main">
+  <p:cSld>
+    <p:spTree>
+      <p:nvGrpSpPr>
+        <p:cNvPr id="1" name=""/>
+        <p:cNvGrpSpPr/>
+        <p:nvPr/>
+      </p:nvGrpSpPr>
+      <p:grpSpPr>
+        <a:xfrm>
+          <a:off x="0" y="0"/>
+          <a:ext cx="0" cy="0"/>
+          <a:chOff x="0" y="0"/>
+          <a:chExt cx="0" cy="0"/>
+        </a:xfrm>
+      </p:grpSpPr>
+      <p:sp>
+        <p:nvSpPr>
+          <p:cNvPr id="2" name="Slide Image Placeholder 1"/>
+          <p:cNvSpPr>
+            <a:spLocks noGrp="1" noRot="1" noChangeAspect="1"/>
+          </p:cNvSpPr>
+          <p:nvPr>
+            <p:ph type="sldImg"/>
+          </p:nvPr>
+        </p:nvSpPr>
+        <p:spPr/>
+      </p:sp>
+      <p:sp>
+        <p:nvSpPr>
+          <p:cNvPr id="3" name="Notes Placeholder 2"/>
+          <p:cNvSpPr>
+            <a:spLocks noGrp="1"/>
+          </p:cNvSpPr>
+          <p:nvPr>
+            <p:ph type="body" idx="1"/>
+          </p:nvPr>
+        </p:nvSpPr>
+        <p:spPr/>
+        <p:txBody>
+          <a:bodyPr/>
+          <a:lstStyle/>
+          <a:p>
+            <a:r>
+              <a:rPr lang="en-US" dirty="0"/>
+              <a:t/>
+            </a:r>
+            <a:endParaRPr lang="en-US" dirty="0"/>
+          </a:p>
+        </p:txBody>
+      </p:sp>
+      <p:sp>
+        <p:nvSpPr>
+          <p:cNvPr id="4" name="Slide Number Placeholder 3"/>
+          <p:cNvSpPr>
+            <a:spLocks noGrp="1"/>
+          </p:cNvSpPr>
+          <p:nvPr>
+            <p:ph type="sldNum" sz="quarter" idx="10"/>
+          </p:nvPr>
+        </p:nvSpPr>
+        <p:spPr/>
+        <p:txBody>
+          <a:bodyPr/>
+          <a:lstStyle/>
+          <a:p>
+            <a:fld id="{F7021451-1387-4CA6-816F-3879F97B5CBC}" type="slidenum">
+              <a:rPr lang="en-US"/>
+              <a:t>10</a:t>
+            </a:fld>
+            <a:endParaRPr lang="en-US"/>
+          </a:p>
+        </p:txBody>
+      </p:sp>
+    </p:spTree>
+    <p:extLst>
+      <p:ext uri="{BB962C8B-B14F-4D97-AF65-F5344CB8AC3E}">
+        <p14:creationId xmlns:p14="http://schemas.microsoft.com/office/powerpoint/2010/main" val="1024086991"/>
+      </p:ext>
+    </p:extLst>
+  </p:cSld>
+  <p:clrMapOvr>
+    <a:masterClrMapping/>
+  </p:clrMapOvr>
+</p:notes>
+</file>
+
+<file path=ppt/notesSlides/notesSlide2.xml><?xml version="1.0" encoding="utf-8"?>
+<p:notes xmlns:a="http://schemas.openxmlformats.org/drawingml/2006/main" xmlns:r="http://schemas.openxmlformats.org/officeDocument/2006/relationships" xmlns:p="http://schemas.openxmlformats.org/presentationml/2006/main">
+  <p:cSld>
+    <p:spTree>
+      <p:nvGrpSpPr>
+        <p:cNvPr id="1" name=""/>
+        <p:cNvGrpSpPr/>
+        <p:nvPr/>
+      </p:nvGrpSpPr>
+      <p:grpSpPr>
+        <a:xfrm>
+          <a:off x="0" y="0"/>
+          <a:ext cx="0" cy="0"/>
+          <a:chOff x="0" y="0"/>
+          <a:chExt cx="0" cy="0"/>
+        </a:xfrm>
+      </p:grpSpPr>
+      <p:sp>
+        <p:nvSpPr>
+          <p:cNvPr id="2" name="Slide Image Placeholder 1"/>
+          <p:cNvSpPr>
+            <a:spLocks noGrp="1" noRot="1" noChangeAspect="1"/>
+          </p:cNvSpPr>
+          <p:nvPr>
+            <p:ph type="sldImg"/>
+          </p:nvPr>
+        </p:nvSpPr>
+        <p:spPr/>
+      </p:sp>
+      <p:sp>
+        <p:nvSpPr>
+          <p:cNvPr id="3" name="Notes Placeholder 2"/>
+          <p:cNvSpPr>
+            <a:spLocks noGrp="1"/>
+          </p:cNvSpPr>
+          <p:nvPr>
+            <p:ph type="body" idx="1"/>
+          </p:nvPr>
+        </p:nvSpPr>
+        <p:spPr/>
+        <p:txBody>
+          <a:bodyPr/>
+          <a:lstStyle/>
+          <a:p>
+            <a:r>
+              <a:rPr lang="en-US" dirty="0"/>
+              <a:t/>
+            </a:r>
+            <a:endParaRPr lang="en-US" dirty="0"/>
+          </a:p>
+        </p:txBody>
+      </p:sp>
+      <p:sp>
+        <p:nvSpPr>
+          <p:cNvPr id="4" name="Slide Number Placeholder 3"/>
+          <p:cNvSpPr>
+            <a:spLocks noGrp="1"/>
+          </p:cNvSpPr>
+          <p:nvPr>
+            <p:ph type="sldNum" sz="quarter" idx="10"/>
+          </p:nvPr>
+        </p:nvSpPr>
+        <p:spPr/>
+        <p:txBody>
+          <a:bodyPr/>
+          <a:lstStyle/>
+          <a:p>
+            <a:fld id="{F7021451-1387-4CA6-816F-3879F97B5CBC}" type="slidenum">
+              <a:rPr lang="en-US"/>
+              <a:t>2</a:t>
+            </a:fld>
+            <a:endParaRPr lang="en-US"/>
+          </a:p>
+        </p:txBody>
+      </p:sp>
+    </p:spTree>
+    <p:extLst>
+      <p:ext uri="{BB962C8B-B14F-4D97-AF65-F5344CB8AC3E}">
+        <p14:creationId xmlns:p14="http://schemas.microsoft.com/office/powerpoint/2010/main" val="1024086991"/>
+      </p:ext>
+    </p:extLst>
+  </p:cSld>
+  <p:clrMapOvr>
+    <a:masterClrMapping/>
+  </p:clrMapOvr>
+</p:notes>
+</file>
+
+<file path=ppt/notesSlides/notesSlide3.xml><?xml version="1.0" encoding="utf-8"?>
+<p:notes xmlns:a="http://schemas.openxmlformats.org/drawingml/2006/main" xmlns:r="http://schemas.openxmlformats.org/officeDocument/2006/relationships" xmlns:p="http://schemas.openxmlformats.org/presentationml/2006/main">
+  <p:cSld>
+    <p:spTree>
+      <p:nvGrpSpPr>
+        <p:cNvPr id="1" name=""/>
+        <p:cNvGrpSpPr/>
+        <p:nvPr/>
+      </p:nvGrpSpPr>
+      <p:grpSpPr>
+        <a:xfrm>
+          <a:off x="0" y="0"/>
+          <a:ext cx="0" cy="0"/>
+          <a:chOff x="0" y="0"/>
+          <a:chExt cx="0" cy="0"/>
+        </a:xfrm>
+      </p:grpSpPr>
+      <p:sp>
+        <p:nvSpPr>
+          <p:cNvPr id="2" name="Slide Image Placeholder 1"/>
+          <p:cNvSpPr>
+            <a:spLocks noGrp="1" noRot="1" noChangeAspect="1"/>
+          </p:cNvSpPr>
+          <p:nvPr>
+            <p:ph type="sldImg"/>
+          </p:nvPr>
+        </p:nvSpPr>
+        <p:spPr/>
+      </p:sp>
+      <p:sp>
+        <p:nvSpPr>
+          <p:cNvPr id="3" name="Notes Placeholder 2"/>
+          <p:cNvSpPr>
+            <a:spLocks noGrp="1"/>
+          </p:cNvSpPr>
+          <p:nvPr>
+            <p:ph type="body" idx="1"/>
+          </p:nvPr>
+        </p:nvSpPr>
+        <p:spPr/>
+        <p:txBody>
+          <a:bodyPr/>
+          <a:lstStyle/>
+          <a:p>
+            <a:r>
+              <a:rPr lang="en-US" dirty="0"/>
+              <a:t/>
+            </a:r>
+            <a:endParaRPr lang="en-US" dirty="0"/>
+          </a:p>
+        </p:txBody>
+      </p:sp>
+      <p:sp>
+        <p:nvSpPr>
+          <p:cNvPr id="4" name="Slide Number Placeholder 3"/>
+          <p:cNvSpPr>
+            <a:spLocks noGrp="1"/>
+          </p:cNvSpPr>
+          <p:nvPr>
+            <p:ph type="sldNum" sz="quarter" idx="10"/>
+          </p:nvPr>
+        </p:nvSpPr>
+        <p:spPr/>
+        <p:txBody>
+          <a:bodyPr/>
+          <a:lstStyle/>
+          <a:p>
+            <a:fld id="{F7021451-1387-4CA6-816F-3879F97B5CBC}" type="slidenum">
+              <a:rPr lang="en-US"/>
+              <a:t>3</a:t>
+            </a:fld>
+            <a:endParaRPr lang="en-US"/>
+          </a:p>
+        </p:txBody>
+      </p:sp>
+    </p:spTree>
+    <p:extLst>
+      <p:ext uri="{BB962C8B-B14F-4D97-AF65-F5344CB8AC3E}">
+        <p14:creationId xmlns:p14="http://schemas.microsoft.com/office/powerpoint/2010/main" val="1024086991"/>
+      </p:ext>
+    </p:extLst>
+  </p:cSld>
+  <p:clrMapOvr>
+    <a:masterClrMapping/>
+  </p:clrMapOvr>
+</p:notes>
+</file>
+
+<file path=ppt/notesSlides/notesSlide4.xml><?xml version="1.0" encoding="utf-8"?>
+<p:notes xmlns:a="http://schemas.openxmlformats.org/drawingml/2006/main" xmlns:r="http://schemas.openxmlformats.org/officeDocument/2006/relationships" xmlns:p="http://schemas.openxmlformats.org/presentationml/2006/main">
+  <p:cSld>
+    <p:spTree>
+      <p:nvGrpSpPr>
+        <p:cNvPr id="1" name=""/>
+        <p:cNvGrpSpPr/>
+        <p:nvPr/>
+      </p:nvGrpSpPr>
+      <p:grpSpPr>
+        <a:xfrm>
+          <a:off x="0" y="0"/>
+          <a:ext cx="0" cy="0"/>
+          <a:chOff x="0" y="0"/>
+          <a:chExt cx="0" cy="0"/>
+        </a:xfrm>
+      </p:grpSpPr>
+      <p:sp>
+        <p:nvSpPr>
+          <p:cNvPr id="2" name="Slide Image Placeholder 1"/>
+          <p:cNvSpPr>
+            <a:spLocks noGrp="1" noRot="1" noChangeAspect="1"/>
+          </p:cNvSpPr>
+          <p:nvPr>
+            <p:ph type="sldImg"/>
+          </p:nvPr>
+        </p:nvSpPr>
+        <p:spPr/>
+      </p:sp>
+      <p:sp>
+        <p:nvSpPr>
+          <p:cNvPr id="3" name="Notes Placeholder 2"/>
+          <p:cNvSpPr>
+            <a:spLocks noGrp="1"/>
+          </p:cNvSpPr>
+          <p:nvPr>
+            <p:ph type="body" idx="1"/>
+          </p:nvPr>
+        </p:nvSpPr>
+        <p:spPr/>
+        <p:txBody>
+          <a:bodyPr/>
+          <a:lstStyle/>
+          <a:p>
+            <a:r>
+              <a:rPr lang="en-US" dirty="0"/>
+              <a:t/>
+            </a:r>
+            <a:endParaRPr lang="en-US" dirty="0"/>
+          </a:p>
+        </p:txBody>
+      </p:sp>
+      <p:sp>
+        <p:nvSpPr>
+          <p:cNvPr id="4" name="Slide Number Placeholder 3"/>
+          <p:cNvSpPr>
+            <a:spLocks noGrp="1"/>
+          </p:cNvSpPr>
+          <p:nvPr>
+            <p:ph type="sldNum" sz="quarter" idx="10"/>
+          </p:nvPr>
+        </p:nvSpPr>
+        <p:spPr/>
+        <p:txBody>
+          <a:bodyPr/>
+          <a:lstStyle/>
+          <a:p>
+            <a:fld id="{F7021451-1387-4CA6-816F-3879F97B5CBC}" type="slidenum">
+              <a:rPr lang="en-US"/>
+              <a:t>4</a:t>
+            </a:fld>
+            <a:endParaRPr lang="en-US"/>
+          </a:p>
+        </p:txBody>
+      </p:sp>
+    </p:spTree>
+    <p:extLst>
+      <p:ext uri="{BB962C8B-B14F-4D97-AF65-F5344CB8AC3E}">
+        <p14:creationId xmlns:p14="http://schemas.microsoft.com/office/powerpoint/2010/main" val="1024086991"/>
+      </p:ext>
+    </p:extLst>
+  </p:cSld>
+  <p:clrMapOvr>
+    <a:masterClrMapping/>
+  </p:clrMapOvr>
+</p:notes>
+</file>
+
+<file path=ppt/notesSlides/notesSlide5.xml><?xml version="1.0" encoding="utf-8"?>
+<p:notes xmlns:a="http://schemas.openxmlformats.org/drawingml/2006/main" xmlns:r="http://schemas.openxmlformats.org/officeDocument/2006/relationships" xmlns:p="http://schemas.openxmlformats.org/presentationml/2006/main">
+  <p:cSld>
+    <p:spTree>
+      <p:nvGrpSpPr>
+        <p:cNvPr id="1" name=""/>
+        <p:cNvGrpSpPr/>
+        <p:nvPr/>
+      </p:nvGrpSpPr>
+      <p:grpSpPr>
+        <a:xfrm>
+          <a:off x="0" y="0"/>
+          <a:ext cx="0" cy="0"/>
+          <a:chOff x="0" y="0"/>
+          <a:chExt cx="0" cy="0"/>
+        </a:xfrm>
+      </p:grpSpPr>
+      <p:sp>
+        <p:nvSpPr>
+          <p:cNvPr id="2" name="Slide Image Placeholder 1"/>
+          <p:cNvSpPr>
+            <a:spLocks noGrp="1" noRot="1" noChangeAspect="1"/>
+          </p:cNvSpPr>
+          <p:nvPr>
+            <p:ph type="sldImg"/>
+          </p:nvPr>
+        </p:nvSpPr>
+        <p:spPr/>
+      </p:sp>
+      <p:sp>
+        <p:nvSpPr>
+          <p:cNvPr id="3" name="Notes Placeholder 2"/>
+          <p:cNvSpPr>
+            <a:spLocks noGrp="1"/>
+          </p:cNvSpPr>
+          <p:nvPr>
+            <p:ph type="body" idx="1"/>
+          </p:nvPr>
+        </p:nvSpPr>
+        <p:spPr/>
+        <p:txBody>
+          <a:bodyPr/>
+          <a:lstStyle/>
+          <a:p>
+            <a:r>
+              <a:rPr lang="en-US" dirty="0"/>
+              <a:t/>
+            </a:r>
+            <a:endParaRPr lang="en-US" dirty="0"/>
+          </a:p>
+        </p:txBody>
+      </p:sp>
+      <p:sp>
+        <p:nvSpPr>
+          <p:cNvPr id="4" name="Slide Number Placeholder 3"/>
+          <p:cNvSpPr>
+            <a:spLocks noGrp="1"/>
+          </p:cNvSpPr>
+          <p:nvPr>
+            <p:ph type="sldNum" sz="quarter" idx="10"/>
+          </p:nvPr>
+        </p:nvSpPr>
+        <p:spPr/>
+        <p:txBody>
+          <a:bodyPr/>
+          <a:lstStyle/>
+          <a:p>
+            <a:fld id="{F7021451-1387-4CA6-816F-3879F97B5CBC}" type="slidenum">
+              <a:rPr lang="en-US"/>
+              <a:t>5</a:t>
+            </a:fld>
+            <a:endParaRPr lang="en-US"/>
+          </a:p>
+        </p:txBody>
+      </p:sp>
+    </p:spTree>
+    <p:extLst>
+      <p:ext uri="{BB962C8B-B14F-4D97-AF65-F5344CB8AC3E}">
+        <p14:creationId xmlns:p14="http://schemas.microsoft.com/office/powerpoint/2010/main" val="1024086991"/>
+      </p:ext>
+    </p:extLst>
+  </p:cSld>
+  <p:clrMapOvr>
+    <a:masterClrMapping/>
+  </p:clrMapOvr>
+</p:notes>
+</file>
+
+<file path=ppt/notesSlides/notesSlide6.xml><?xml version="1.0" encoding="utf-8"?>
+<p:notes xmlns:a="http://schemas.openxmlformats.org/drawingml/2006/main" xmlns:r="http://schemas.openxmlformats.org/officeDocument/2006/relationships" xmlns:p="http://schemas.openxmlformats.org/presentationml/2006/main">
+  <p:cSld>
+    <p:spTree>
+      <p:nvGrpSpPr>
+        <p:cNvPr id="1" name=""/>
+        <p:cNvGrpSpPr/>
+        <p:nvPr/>
+      </p:nvGrpSpPr>
+      <p:grpSpPr>
+        <a:xfrm>
+          <a:off x="0" y="0"/>
+          <a:ext cx="0" cy="0"/>
+          <a:chOff x="0" y="0"/>
+          <a:chExt cx="0" cy="0"/>
+        </a:xfrm>
+      </p:grpSpPr>
+      <p:sp>
+        <p:nvSpPr>
+          <p:cNvPr id="2" name="Slide Image Placeholder 1"/>
+          <p:cNvSpPr>
+            <a:spLocks noGrp="1" noRot="1" noChangeAspect="1"/>
+          </p:cNvSpPr>
+          <p:nvPr>
+            <p:ph type="sldImg"/>
+          </p:nvPr>
+        </p:nvSpPr>
+        <p:spPr/>
+      </p:sp>
+      <p:sp>
+        <p:nvSpPr>
+          <p:cNvPr id="3" name="Notes Placeholder 2"/>
+          <p:cNvSpPr>
+            <a:spLocks noGrp="1"/>
+          </p:cNvSpPr>
+          <p:nvPr>
+            <p:ph type="body" idx="1"/>
+          </p:nvPr>
+        </p:nvSpPr>
+        <p:spPr/>
+        <p:txBody>
+          <a:bodyPr/>
+          <a:lstStyle/>
+          <a:p>
+            <a:r>
+              <a:rPr lang="en-US" dirty="0"/>
+              <a:t/>
+            </a:r>
+            <a:endParaRPr lang="en-US" dirty="0"/>
+          </a:p>
+        </p:txBody>
+      </p:sp>
+      <p:sp>
+        <p:nvSpPr>
+          <p:cNvPr id="4" name="Slide Number Placeholder 3"/>
+          <p:cNvSpPr>
+            <a:spLocks noGrp="1"/>
+          </p:cNvSpPr>
+          <p:nvPr>
+            <p:ph type="sldNum" sz="quarter" idx="10"/>
+          </p:nvPr>
+        </p:nvSpPr>
+        <p:spPr/>
+        <p:txBody>
+          <a:bodyPr/>
+          <a:lstStyle/>
+          <a:p>
+            <a:fld id="{F7021451-1387-4CA6-816F-3879F97B5CBC}" type="slidenum">
+              <a:rPr lang="en-US"/>
+              <a:t>6</a:t>
+            </a:fld>
+            <a:endParaRPr lang="en-US"/>
+          </a:p>
+        </p:txBody>
+      </p:sp>
+    </p:spTree>
+    <p:extLst>
+      <p:ext uri="{BB962C8B-B14F-4D97-AF65-F5344CB8AC3E}">
+        <p14:creationId xmlns:p14="http://schemas.microsoft.com/office/powerpoint/2010/main" val="1024086991"/>
+      </p:ext>
+    </p:extLst>
+  </p:cSld>
+  <p:clrMapOvr>
+    <a:masterClrMapping/>
+  </p:clrMapOvr>
+</p:notes>
+</file>
+
+<file path=ppt/notesSlides/notesSlide7.xml><?xml version="1.0" encoding="utf-8"?>
+<p:notes xmlns:a="http://schemas.openxmlformats.org/drawingml/2006/main" xmlns:r="http://schemas.openxmlformats.org/officeDocument/2006/relationships" xmlns:p="http://schemas.openxmlformats.org/presentationml/2006/main">
+  <p:cSld>
+    <p:spTree>
+      <p:nvGrpSpPr>
+        <p:cNvPr id="1" name=""/>
+        <p:cNvGrpSpPr/>
+        <p:nvPr/>
+      </p:nvGrpSpPr>
+      <p:grpSpPr>
+        <a:xfrm>
+          <a:off x="0" y="0"/>
+          <a:ext cx="0" cy="0"/>
+          <a:chOff x="0" y="0"/>
+          <a:chExt cx="0" cy="0"/>
+        </a:xfrm>
+      </p:grpSpPr>
+      <p:sp>
+        <p:nvSpPr>
+          <p:cNvPr id="2" name="Slide Image Placeholder 1"/>
+          <p:cNvSpPr>
+            <a:spLocks noGrp="1" noRot="1" noChangeAspect="1"/>
+          </p:cNvSpPr>
+          <p:nvPr>
+            <p:ph type="sldImg"/>
+          </p:nvPr>
+        </p:nvSpPr>
+        <p:spPr/>
+      </p:sp>
+      <p:sp>
+        <p:nvSpPr>
+          <p:cNvPr id="3" name="Notes Placeholder 2"/>
+          <p:cNvSpPr>
+            <a:spLocks noGrp="1"/>
+          </p:cNvSpPr>
+          <p:nvPr>
+            <p:ph type="body" idx="1"/>
+          </p:nvPr>
+        </p:nvSpPr>
+        <p:spPr/>
+        <p:txBody>
+          <a:bodyPr/>
+          <a:lstStyle/>
+          <a:p>
+            <a:r>
+              <a:rPr lang="en-US" dirty="0"/>
+              <a:t/>
+            </a:r>
+            <a:endParaRPr lang="en-US" dirty="0"/>
+          </a:p>
+        </p:txBody>
+      </p:sp>
+      <p:sp>
+        <p:nvSpPr>
+          <p:cNvPr id="4" name="Slide Number Placeholder 3"/>
+          <p:cNvSpPr>
+            <a:spLocks noGrp="1"/>
+          </p:cNvSpPr>
+          <p:nvPr>
+            <p:ph type="sldNum" sz="quarter" idx="10"/>
+          </p:nvPr>
+        </p:nvSpPr>
+        <p:spPr/>
+        <p:txBody>
+          <a:bodyPr/>
+          <a:lstStyle/>
+          <a:p>
+            <a:fld id="{F7021451-1387-4CA6-816F-3879F97B5CBC}" type="slidenum">
+              <a:rPr lang="en-US"/>
+              <a:t>7</a:t>
+            </a:fld>
+            <a:endParaRPr lang="en-US"/>
+          </a:p>
+        </p:txBody>
+      </p:sp>
+    </p:spTree>
+    <p:extLst>
+      <p:ext uri="{BB962C8B-B14F-4D97-AF65-F5344CB8AC3E}">
+        <p14:creationId xmlns:p14="http://schemas.microsoft.com/office/powerpoint/2010/main" val="1024086991"/>
+      </p:ext>
+    </p:extLst>
+  </p:cSld>
+  <p:clrMapOvr>
+    <a:masterClrMapping/>
+  </p:clrMapOvr>
+</p:notes>
+</file>
+
+<file path=ppt/notesSlides/notesSlide8.xml><?xml version="1.0" encoding="utf-8"?>
+<p:notes xmlns:a="http://schemas.openxmlformats.org/drawingml/2006/main" xmlns:r="http://schemas.openxmlformats.org/officeDocument/2006/relationships" xmlns:p="http://schemas.openxmlformats.org/presentationml/2006/main">
+  <p:cSld>
+    <p:spTree>
+      <p:nvGrpSpPr>
+        <p:cNvPr id="1" name=""/>
+        <p:cNvGrpSpPr/>
+        <p:nvPr/>
+      </p:nvGrpSpPr>
+      <p:grpSpPr>
+        <a:xfrm>
+          <a:off x="0" y="0"/>
+          <a:ext cx="0" cy="0"/>
+          <a:chOff x="0" y="0"/>
+          <a:chExt cx="0" cy="0"/>
+        </a:xfrm>
+      </p:grpSpPr>
+      <p:sp>
+        <p:nvSpPr>
+          <p:cNvPr id="2" name="Slide Image Placeholder 1"/>
+          <p:cNvSpPr>
+            <a:spLocks noGrp="1" noRot="1" noChangeAspect="1"/>
+          </p:cNvSpPr>
+          <p:nvPr>
+            <p:ph type="sldImg"/>
+          </p:nvPr>
+        </p:nvSpPr>
+        <p:spPr/>
+      </p:sp>
+      <p:sp>
+        <p:nvSpPr>
+          <p:cNvPr id="3" name="Notes Placeholder 2"/>
+          <p:cNvSpPr>
+            <a:spLocks noGrp="1"/>
+          </p:cNvSpPr>
+          <p:nvPr>
+            <p:ph type="body" idx="1"/>
+          </p:nvPr>
+        </p:nvSpPr>
+        <p:spPr/>
+        <p:txBody>
+          <a:bodyPr/>
+          <a:lstStyle/>
+          <a:p>
+            <a:r>
+              <a:rPr lang="en-US" dirty="0"/>
+              <a:t/>
+            </a:r>
+            <a:endParaRPr lang="en-US" dirty="0"/>
+          </a:p>
+        </p:txBody>
+      </p:sp>
+      <p:sp>
+        <p:nvSpPr>
+          <p:cNvPr id="4" name="Slide Number Placeholder 3"/>
+          <p:cNvSpPr>
+            <a:spLocks noGrp="1"/>
+          </p:cNvSpPr>
+          <p:nvPr>
+            <p:ph type="sldNum" sz="quarter" idx="10"/>
+          </p:nvPr>
+        </p:nvSpPr>
+        <p:spPr/>
+        <p:txBody>
+          <a:bodyPr/>
+          <a:lstStyle/>
+          <a:p>
+            <a:fld id="{F7021451-1387-4CA6-816F-3879F97B5CBC}" type="slidenum">
+              <a:rPr lang="en-US"/>
+              <a:t>8</a:t>
+            </a:fld>
+            <a:endParaRPr lang="en-US"/>
+          </a:p>
+        </p:txBody>
+      </p:sp>
+    </p:spTree>
+    <p:extLst>
+      <p:ext uri="{BB962C8B-B14F-4D97-AF65-F5344CB8AC3E}">
+        <p14:creationId xmlns:p14="http://schemas.microsoft.com/office/powerpoint/2010/main" val="1024086991"/>
+      </p:ext>
+    </p:extLst>
+  </p:cSld>
+  <p:clrMapOvr>
+    <a:masterClrMapping/>
+  </p:clrMapOvr>
+</p:notes>
+</file>
+
+<file path=ppt/notesSlides/notesSlide9.xml><?xml version="1.0" encoding="utf-8"?>
+<p:notes xmlns:a="http://schemas.openxmlformats.org/drawingml/2006/main" xmlns:r="http://schemas.openxmlformats.org/officeDocument/2006/relationships" xmlns:p="http://schemas.openxmlformats.org/presentationml/2006/main">
+  <p:cSld>
+    <p:spTree>
+      <p:nvGrpSpPr>
+        <p:cNvPr id="1" name=""/>
+        <p:cNvGrpSpPr/>
+        <p:nvPr/>
+      </p:nvGrpSpPr>
+      <p:grpSpPr>
+        <a:xfrm>
+          <a:off x="0" y="0"/>
+          <a:ext cx="0" cy="0"/>
+          <a:chOff x="0" y="0"/>
+          <a:chExt cx="0" cy="0"/>
+        </a:xfrm>
+      </p:grpSpPr>
+      <p:sp>
+        <p:nvSpPr>
+          <p:cNvPr id="2" name="Slide Image Placeholder 1"/>
+          <p:cNvSpPr>
+            <a:spLocks noGrp="1" noRot="1" noChangeAspect="1"/>
+          </p:cNvSpPr>
+          <p:nvPr>
+            <p:ph type="sldImg"/>
+          </p:nvPr>
+        </p:nvSpPr>
+        <p:spPr/>
+      </p:sp>
+      <p:sp>
+        <p:nvSpPr>
+          <p:cNvPr id="3" name="Notes Placeholder 2"/>
+          <p:cNvSpPr>
+            <a:spLocks noGrp="1"/>
+          </p:cNvSpPr>
+          <p:nvPr>
+            <p:ph type="body" idx="1"/>
+          </p:nvPr>
+        </p:nvSpPr>
+        <p:spPr/>
+        <p:txBody>
+          <a:bodyPr/>
+          <a:lstStyle/>
+          <a:p>
+            <a:r>
+              <a:rPr lang="en-US" dirty="0"/>
+              <a:t/>
+            </a:r>
+            <a:endParaRPr lang="en-US" dirty="0"/>
+          </a:p>
+        </p:txBody>
+      </p:sp>
+      <p:sp>
+        <p:nvSpPr>
+          <p:cNvPr id="4" name="Slide Number Placeholder 3"/>
+          <p:cNvSpPr>
+            <a:spLocks noGrp="1"/>
+          </p:cNvSpPr>
+          <p:nvPr>
+            <p:ph type="sldNum" sz="quarter" idx="10"/>
+          </p:nvPr>
+        </p:nvSpPr>
+        <p:spPr/>
+        <p:txBody>
+          <a:bodyPr/>
+          <a:lstStyle/>
+          <a:p>
+            <a:fld id="{F7021451-1387-4CA6-816F-3879F97B5CBC}" type="slidenum">
+              <a:rPr lang="en-US"/>
+              <a:t>9</a:t>
+            </a:fld>
+            <a:endParaRPr lang="en-US"/>
+          </a:p>
+        </p:txBody>
+      </p:sp>
+    </p:spTree>
+    <p:extLst>
+      <p:ext uri="{BB962C8B-B14F-4D97-AF65-F5344CB8AC3E}">
+        <p14:creationId xmlns:p14="http://schemas.microsoft.com/office/powerpoint/2010/main" val="1024086991"/>
+      </p:ext>
+    </p:extLst>
+  </p:cSld>
+  <p:clrMapOvr>
+    <a:masterClrMapping/>
+  </p:clrMapOvr>
+</p:notes>
 </file>
 
 <file path=ppt/slideLayouts/slideLayout1.xml><?xml version="1.0" encoding="utf-8"?>
@@ -1592,8 +2911,370 @@
 </p:sld>
 </file>
 
-<file path=ppt/slides/slide4.xml><?xml version="1.0" encoding="UTF-8" standalone="yes"?>
-<p:sld xmlns:a="http://schemas.openxmlformats.org/drawingml/2006/main" xmlns:r="http://schemas.openxmlformats.org/officeDocument/2006/relationships" xmlns:p="http://schemas.openxmlformats.org/presentationml/2006/main"><p:cSld name="Du lịch truyền thống & du lịch xanh"><p:bg><p:bgPr><a:solidFill><a:srgbClr val="FAF8F2"/></a:solidFill><a:effectLst/></p:bgPr></p:bg><p:spTree><p:nvGrpSpPr><p:cNvPr id="1" name=""/><p:cNvGrpSpPr/><p:nvPr/></p:nvGrpSpPr><p:grpSpPr><a:xfrm><a:off x="0" y="0"/><a:ext cx="0" cy="0"/><a:chOff x="0" y="0"/><a:chExt cx="0" cy="0"/></a:xfrm></p:grpSpPr><p:sp><p:nvSpPr><p:cNvPr id="2" name="Shape 2"/><p:cNvSpPr/><p:nvPr/></p:nvSpPr><p:spPr><a:xfrm><a:off x="0" y="0"/><a:ext cx="12192000" cy="1143000"/></a:xfrm><a:prstGeom prst="rect"><a:avLst/></a:prstGeom><a:solidFill><a:srgbClr val="0E3B2E"/></a:solidFill><a:ln/></p:spPr><p:txBody><a:bodyPr/><a:lstStyle/><a:p><a:pPr><a:buNone/></a:pPr><a:endParaRPr lang="vi-VN"/></a:p></p:txBody></p:sp><p:sp><p:nvSpPr><p:cNvPr id="3" name="Text 3"/><p:cNvSpPr/><p:nvPr/></p:nvSpPr><p:spPr><a:xfrm><a:off x="838200" y="228600"/><a:ext cx="1000000" cy="500000"/></a:xfrm><a:prstGeom prst="rect"><a:avLst/></a:prstGeom><a:noFill/><a:ln/></p:spPr><p:txBody><a:bodyPr wrap="square" rtlCol="0" anchor="t"><a:normAutofit/></a:bodyPr><a:lstStyle/><a:p><a:pPr algn="l" marL="0" indent="0"><a:buNone/></a:pPr><a:r><a:rPr lang="vi-VN" sz="2400" b="1" dirty="0"><a:solidFill><a:srgbClr val="D9A441"/></a:solidFill><a:latin typeface="Cambria" pitchFamily="34" charset="0"/><a:ea typeface="Cambria" pitchFamily="34" charset="-122"/><a:cs typeface="Cambria" pitchFamily="34" charset="-120"/></a:rPr><a:t>02</a:t></a:r></a:p></p:txBody></p:sp><p:sp><p:nvSpPr><p:cNvPr id="4" name="Text 4"/><p:cNvSpPr/><p:nvPr/></p:nvSpPr><p:spPr><a:xfrm><a:off x="1638300" y="274320"/><a:ext cx="9715500" cy="600000"/></a:xfrm><a:prstGeom prst="rect"><a:avLst/></a:prstGeom><a:noFill/><a:ln/></p:spPr><p:txBody><a:bodyPr wrap="square" rtlCol="0" anchor="t"><a:normAutofit/></a:bodyPr><a:lstStyle/><a:p><a:pPr algn="l" marL="0" indent="0"><a:buNone/></a:pPr><a:r><a:rPr lang="vi-VN" sz="2200" b="1" dirty="0"><a:solidFill><a:srgbClr val="FFFFFF"/></a:solidFill><a:latin typeface="Cambria" pitchFamily="34" charset="0"/><a:ea typeface="Cambria" pitchFamily="34" charset="-122"/><a:cs typeface="Cambria" pitchFamily="34" charset="-120"/></a:rPr><a:t>Du lịch truyền thống &amp; du lịch xanh</a:t></a:r></a:p></p:txBody></p:sp><p:sp><p:nvSpPr><p:cNvPr id="5" name="Text 5"/><p:cNvSpPr/><p:nvPr/></p:nvSpPr><p:spPr><a:xfrm><a:off x="838200" y="1524000"/><a:ext cx="10515600" cy="3200000"/></a:xfrm><a:prstGeom prst="rect"><a:avLst/></a:prstGeom><a:noFill/><a:ln/></p:spPr><p:txBody><a:bodyPr wrap="square" rtlCol="0" anchor="t"><a:normAutofit/></a:bodyPr><a:lstStyle/><a:p><a:pPr algn="l" marL="216000" indent="-216000"><a:buFont typeface="Arial" pitchFamily="34" charset="0"/><a:buChar char="&#8226;"/></a:pPr><a:r><a:rPr lang="vi-VN" sz="1400" dirty="0"><a:solidFill><a:srgbClr val="1F2A24"/></a:solidFill><a:latin typeface="Calibri" pitchFamily="34" charset="0"/><a:ea typeface="Calibri" pitchFamily="34" charset="-122"/><a:cs typeface="Calibri" pitchFamily="34" charset="-120"/></a:rPr><a:t>Truyền thống: chú trọng số lượng khách, doanh thu nhanh; dễ gây rác thải, quá tải điểm đến, tiêu tốn năng lượng.</a:t></a:r></a:p><a:p><a:pPr algn="l" marL="216000" indent="-216000"><a:spcBef><a:spcPts val="900"/></a:spcBef><a:buFont typeface="Arial" pitchFamily="34" charset="0"/><a:buChar char="&#8226;"/></a:pPr><a:r><a:rPr lang="vi-VN" sz="1400" dirty="0"><a:solidFill><a:srgbClr val="1F2A24"/></a:solidFill><a:latin typeface="Calibri" pitchFamily="34" charset="0"/><a:ea typeface="Calibri" pitchFamily="34" charset="-122"/><a:cs typeface="Calibri" pitchFamily="34" charset="-120"/></a:rPr><a:t>Du lịch xanh: chú trọng chất lượng trải nghiệm, bảo tồn tự nhiên, chia sẻ lợi ích với người dân địa phương.</a:t></a:r></a:p><a:p><a:pPr algn="l" marL="216000" indent="-216000"><a:spcBef><a:spcPts val="900"/></a:spcBef><a:buFont typeface="Arial" pitchFamily="34" charset="0"/><a:buChar char="&#8226;"/></a:pPr><a:r><a:rPr lang="vi-VN" sz="1400" dirty="0"><a:solidFill><a:srgbClr val="1F2A24"/></a:solidFill><a:latin typeface="Calibri" pitchFamily="34" charset="0"/><a:ea typeface="Calibri" pitchFamily="34" charset="-122"/><a:cs typeface="Calibri" pitchFamily="34" charset="-120"/></a:rPr><a:t>Hai hình thức không loại trừ nhau — xu hướng là “xanh hoá” dần các sản phẩm du lịch hiện có.</a:t></a:r></a:p></p:txBody></p:sp><p:sp><p:nvSpPr><p:cNvPr id="6" name="Shape 6"/><p:cNvSpPr/><p:nvPr/></p:nvSpPr><p:spPr><a:xfrm><a:off x="838200" y="4876800"/><a:ext cx="10515600" cy="1000000"/></a:xfrm><a:prstGeom prst="roundRect"><a:avLst><a:gd name="adj" fmla="val 4000"/></a:avLst></a:prstGeom><a:solidFill><a:srgbClr val="ECEFE1"/></a:solidFill><a:ln/></p:spPr><p:txBody><a:bodyPr/><a:lstStyle/><a:p><a:pPr><a:buNone/></a:pPr><a:endParaRPr lang="vi-VN"/></a:p></p:txBody></p:sp><p:sp><p:nvSpPr><p:cNvPr id="7" name="Shape 7"/><p:cNvSpPr/><p:nvPr/></p:nvSpPr><p:spPr><a:xfrm><a:off x="838200" y="4876800"/><a:ext cx="45720" cy="1000000"/></a:xfrm><a:prstGeom prst="rect"><a:avLst/></a:prstGeom><a:solidFill><a:srgbClr val="D9A441"/></a:solidFill><a:ln/></p:spPr><p:txBody><a:bodyPr/><a:lstStyle/><a:p><a:pPr><a:buNone/></a:pPr><a:endParaRPr lang="vi-VN"/></a:p></p:txBody></p:sp><p:sp><p:nvSpPr><p:cNvPr id="8" name="Text 8"/><p:cNvSpPr/><p:nvPr/></p:nvSpPr><p:spPr><a:xfrm><a:off x="1021080" y="4968240"/><a:ext cx="10149840" cy="300000"/></a:xfrm><a:prstGeom prst="rect"><a:avLst/></a:prstGeom><a:noFill/><a:ln/></p:spPr><p:txBody><a:bodyPr wrap="square" rtlCol="0" anchor="t"><a:normAutofit/></a:bodyPr><a:lstStyle/><a:p><a:pPr algn="l" marL="0" indent="0"><a:buNone/></a:pPr><a:r><a:rPr lang="vi-VN" sz="1000" b="1" dirty="0"><a:solidFill><a:srgbClr val="D9A441"/></a:solidFill><a:latin typeface="Calibri" pitchFamily="34" charset="0"/><a:ea typeface="Calibri" pitchFamily="34" charset="-122"/><a:cs typeface="Calibri" pitchFamily="34" charset="-120"/></a:rPr><a:t>VÍ DỤ</a:t></a:r></a:p></p:txBody></p:sp><p:sp><p:nvSpPr><p:cNvPr id="9" name="Text 9"/><p:cNvSpPr/><p:nvPr/></p:nvSpPr><p:spPr><a:xfrm><a:off x="1021080" y="5257800"/><a:ext cx="10149840" cy="550000"/></a:xfrm><a:prstGeom prst="rect"><a:avLst/></a:prstGeom><a:noFill/><a:ln/></p:spPr><p:txBody><a:bodyPr wrap="square" rtlCol="0" anchor="t"><a:normAutofit/></a:bodyPr><a:lstStyle/><a:p><a:pPr algn="l" marL="0" indent="0"><a:buNone/></a:pPr><a:r><a:rPr lang="vi-VN" sz="1200" i="1" dirty="0"><a:solidFill><a:srgbClr val="5B6B62"/></a:solidFill><a:latin typeface="Calibri" pitchFamily="34" charset="0"/><a:ea typeface="Calibri" pitchFamily="34" charset="-122"/><a:cs typeface="Calibri" pitchFamily="34" charset="-120"/></a:rPr><a:t>Một tour tham quan trung tâm bằng xe buýt điện hoặc buýt đường sông trên sông Sài Gòn giúp giảm khí thải so với việc mỗi nhóm khách thuê riêng một xe ô tô.</a:t></a:r></a:p></p:txBody></p:sp></p:spTree></p:cSld><p:clrMapOvr><a:masterClrMapping/></p:clrMapOvr></p:sld>
+<file path=ppt/slides/slide4.xml><?xml version="1.0" encoding="utf-8"?>
+<p:sld xmlns:a="http://schemas.openxmlformats.org/drawingml/2006/main" xmlns:r="http://schemas.openxmlformats.org/officeDocument/2006/relationships" xmlns:p="http://schemas.openxmlformats.org/presentationml/2006/main">
+  <p:cSld name="Du lịch truyền thống &amp; du lịch xanh">
+    <p:bg>
+      <p:bgPr>
+        <a:solidFill>
+          <a:srgbClr val="FAF8F2"/>
+        </a:solidFill>
+        <a:effectLst/>
+      </p:bgPr>
+    </p:bg>
+    <p:spTree>
+      <p:nvGrpSpPr>
+        <p:cNvPr id="1" name=""/>
+        <p:cNvGrpSpPr/>
+        <p:nvPr/>
+      </p:nvGrpSpPr>
+      <p:grpSpPr>
+        <a:xfrm>
+          <a:off x="0" y="0"/>
+          <a:ext cx="0" cy="0"/>
+          <a:chOff x="0" y="0"/>
+          <a:chExt cx="0" cy="0"/>
+        </a:xfrm>
+      </p:grpSpPr>
+      <p:sp>
+        <p:nvSpPr>
+          <p:cNvPr id="2" name="Shape 2"/>
+          <p:cNvSpPr/>
+          <p:nvPr/>
+        </p:nvSpPr>
+        <p:spPr>
+          <a:xfrm>
+            <a:off x="0" y="0"/>
+            <a:ext cx="12192000" cy="1143000"/>
+          </a:xfrm>
+          <a:prstGeom prst="rect">
+            <a:avLst/>
+          </a:prstGeom>
+          <a:solidFill>
+            <a:srgbClr val="0E3B2E"/>
+          </a:solidFill>
+          <a:ln/>
+        </p:spPr>
+        <p:txBody>
+          <a:bodyPr/>
+          <a:lstStyle/>
+          <a:p>
+            <a:pPr>
+              <a:buNone/>
+            </a:pPr>
+            <a:endParaRPr lang="vi-VN"/>
+          </a:p>
+        </p:txBody>
+      </p:sp>
+      <p:sp>
+        <p:nvSpPr>
+          <p:cNvPr id="3" name="Text 3"/>
+          <p:cNvSpPr/>
+          <p:nvPr/>
+        </p:nvSpPr>
+        <p:spPr>
+          <a:xfrm>
+            <a:off x="838200" y="228600"/>
+            <a:ext cx="1000000" cy="500000"/>
+          </a:xfrm>
+          <a:prstGeom prst="rect">
+            <a:avLst/>
+          </a:prstGeom>
+          <a:noFill/>
+          <a:ln/>
+        </p:spPr>
+        <p:txBody>
+          <a:bodyPr wrap="square" rtlCol="0" anchor="t">
+            <a:normAutofit/>
+          </a:bodyPr>
+          <a:lstStyle/>
+          <a:p>
+            <a:pPr algn="l" marL="0" indent="0">
+              <a:buNone/>
+            </a:pPr>
+            <a:r>
+              <a:rPr lang="vi-VN" sz="2400" b="1" dirty="0">
+                <a:solidFill>
+                  <a:srgbClr val="D9A441"/>
+                </a:solidFill>
+                <a:latin typeface="Cambria" pitchFamily="34" charset="0"/>
+                <a:ea typeface="Cambria" pitchFamily="34" charset="-122"/>
+                <a:cs typeface="Cambria" pitchFamily="34" charset="-120"/>
+              </a:rPr>
+              <a:t>02</a:t>
+            </a:r>
+          </a:p>
+        </p:txBody>
+      </p:sp>
+      <p:sp>
+        <p:nvSpPr>
+          <p:cNvPr id="4" name="Text 4"/>
+          <p:cNvSpPr/>
+          <p:nvPr/>
+        </p:nvSpPr>
+        <p:spPr>
+          <a:xfrm>
+            <a:off x="1638300" y="274320"/>
+            <a:ext cx="9715500" cy="600000"/>
+          </a:xfrm>
+          <a:prstGeom prst="rect">
+            <a:avLst/>
+          </a:prstGeom>
+          <a:noFill/>
+          <a:ln/>
+        </p:spPr>
+        <p:txBody>
+          <a:bodyPr wrap="square" rtlCol="0" anchor="t">
+            <a:normAutofit/>
+          </a:bodyPr>
+          <a:lstStyle/>
+          <a:p>
+            <a:pPr algn="l" marL="0" indent="0">
+              <a:buNone/>
+            </a:pPr>
+            <a:r>
+              <a:rPr lang="vi-VN" sz="2200" b="1" dirty="0">
+                <a:solidFill>
+                  <a:srgbClr val="FFFFFF"/>
+                </a:solidFill>
+                <a:latin typeface="Cambria" pitchFamily="34" charset="0"/>
+                <a:ea typeface="Cambria" pitchFamily="34" charset="-122"/>
+                <a:cs typeface="Cambria" pitchFamily="34" charset="-120"/>
+              </a:rPr>
+              <a:t>Du lịch truyền thống &amp; du lịch xanh</a:t>
+            </a:r>
+          </a:p>
+        </p:txBody>
+      </p:sp>
+      <p:sp>
+        <p:nvSpPr>
+          <p:cNvPr id="5" name="Text 5"/>
+          <p:cNvSpPr/>
+          <p:nvPr/>
+        </p:nvSpPr>
+        <p:spPr>
+          <a:xfrm>
+            <a:off x="838200" y="1524000"/>
+            <a:ext cx="10515600" cy="3200000"/>
+          </a:xfrm>
+          <a:prstGeom prst="rect">
+            <a:avLst/>
+          </a:prstGeom>
+          <a:noFill/>
+          <a:ln/>
+        </p:spPr>
+        <p:txBody>
+          <a:bodyPr wrap="square" rtlCol="0" anchor="t">
+            <a:normAutofit/>
+          </a:bodyPr>
+          <a:lstStyle/>
+          <a:p>
+            <a:pPr algn="l" marL="216000" indent="-216000">
+              <a:buFont typeface="Arial" pitchFamily="34" charset="0"/>
+              <a:buChar char="•"/>
+            </a:pPr>
+            <a:r>
+              <a:rPr lang="vi-VN" sz="1400" dirty="0">
+                <a:solidFill>
+                  <a:srgbClr val="1F2A24"/>
+                </a:solidFill>
+                <a:latin typeface="Calibri" pitchFamily="34" charset="0"/>
+                <a:ea typeface="Calibri" pitchFamily="34" charset="-122"/>
+                <a:cs typeface="Calibri" pitchFamily="34" charset="-120"/>
+              </a:rPr>
+              <a:t>Truyền thống: chú trọng số lượng khách, doanh thu nhanh; dễ gây rác thải, quá tải điểm đến, tiêu tốn năng lượng.</a:t>
+            </a:r>
+          </a:p>
+          <a:p>
+            <a:pPr algn="l" marL="216000" indent="-216000">
+              <a:spcBef>
+                <a:spcPts val="900"/>
+              </a:spcBef>
+              <a:buFont typeface="Arial" pitchFamily="34" charset="0"/>
+              <a:buChar char="•"/>
+            </a:pPr>
+            <a:r>
+              <a:rPr lang="vi-VN" sz="1400" dirty="0">
+                <a:solidFill>
+                  <a:srgbClr val="1F2A24"/>
+                </a:solidFill>
+                <a:latin typeface="Calibri" pitchFamily="34" charset="0"/>
+                <a:ea typeface="Calibri" pitchFamily="34" charset="-122"/>
+                <a:cs typeface="Calibri" pitchFamily="34" charset="-120"/>
+              </a:rPr>
+              <a:t>Du lịch xanh: chú trọng chất lượng trải nghiệm, bảo tồn tự nhiên, chia sẻ lợi ích với người dân địa phương.</a:t>
+            </a:r>
+          </a:p>
+          <a:p>
+            <a:pPr algn="l" marL="216000" indent="-216000">
+              <a:spcBef>
+                <a:spcPts val="900"/>
+              </a:spcBef>
+              <a:buFont typeface="Arial" pitchFamily="34" charset="0"/>
+              <a:buChar char="•"/>
+            </a:pPr>
+            <a:r>
+              <a:rPr lang="vi-VN" sz="1400" dirty="0">
+                <a:solidFill>
+                  <a:srgbClr val="1F2A24"/>
+                </a:solidFill>
+                <a:latin typeface="Calibri" pitchFamily="34" charset="0"/>
+                <a:ea typeface="Calibri" pitchFamily="34" charset="-122"/>
+                <a:cs typeface="Calibri" pitchFamily="34" charset="-120"/>
+              </a:rPr>
+              <a:t>Hai hình thức không loại trừ nhau — xu hướng là “xanh hoá” dần các sản phẩm du lịch hiện có.</a:t>
+            </a:r>
+          </a:p>
+        </p:txBody>
+      </p:sp>
+      <p:sp>
+        <p:nvSpPr>
+          <p:cNvPr id="6" name="Shape 6"/>
+          <p:cNvSpPr/>
+          <p:nvPr/>
+        </p:nvSpPr>
+        <p:spPr>
+          <a:xfrm>
+            <a:off x="838200" y="4876800"/>
+            <a:ext cx="10515600" cy="1000000"/>
+          </a:xfrm>
+          <a:prstGeom prst="roundRect">
+            <a:avLst>
+              <a:gd name="adj" fmla="val 4000"/>
+            </a:avLst>
+          </a:prstGeom>
+          <a:solidFill>
+            <a:srgbClr val="ECEFE1"/>
+          </a:solidFill>
+          <a:ln/>
+        </p:spPr>
+        <p:txBody>
+          <a:bodyPr/>
+          <a:lstStyle/>
+          <a:p>
+            <a:pPr>
+              <a:buNone/>
+            </a:pPr>
+            <a:endParaRPr lang="vi-VN"/>
+          </a:p>
+        </p:txBody>
+      </p:sp>
+      <p:sp>
+        <p:nvSpPr>
+          <p:cNvPr id="7" name="Shape 7"/>
+          <p:cNvSpPr/>
+          <p:nvPr/>
+        </p:nvSpPr>
+        <p:spPr>
+          <a:xfrm>
+            <a:off x="838200" y="4876800"/>
+            <a:ext cx="45720" cy="1000000"/>
+          </a:xfrm>
+          <a:prstGeom prst="rect">
+            <a:avLst/>
+          </a:prstGeom>
+          <a:solidFill>
+            <a:srgbClr val="D9A441"/>
+          </a:solidFill>
+          <a:ln/>
+        </p:spPr>
+        <p:txBody>
+          <a:bodyPr/>
+          <a:lstStyle/>
+          <a:p>
+            <a:pPr>
+              <a:buNone/>
+            </a:pPr>
+            <a:endParaRPr lang="vi-VN"/>
+          </a:p>
+        </p:txBody>
+      </p:sp>
+      <p:sp>
+        <p:nvSpPr>
+          <p:cNvPr id="8" name="Text 8"/>
+          <p:cNvSpPr/>
+          <p:nvPr/>
+        </p:nvSpPr>
+        <p:spPr>
+          <a:xfrm>
+            <a:off x="1021080" y="4968240"/>
+            <a:ext cx="10149840" cy="300000"/>
+          </a:xfrm>
+          <a:prstGeom prst="rect">
+            <a:avLst/>
+          </a:prstGeom>
+          <a:noFill/>
+          <a:ln/>
+        </p:spPr>
+        <p:txBody>
+          <a:bodyPr wrap="square" rtlCol="0" anchor="t">
+            <a:normAutofit/>
+          </a:bodyPr>
+          <a:lstStyle/>
+          <a:p>
+            <a:pPr algn="l" marL="0" indent="0">
+              <a:buNone/>
+            </a:pPr>
+            <a:r>
+              <a:rPr lang="vi-VN" sz="1000" b="1" dirty="0">
+                <a:solidFill>
+                  <a:srgbClr val="D9A441"/>
+                </a:solidFill>
+                <a:latin typeface="Calibri" pitchFamily="34" charset="0"/>
+                <a:ea typeface="Calibri" pitchFamily="34" charset="-122"/>
+                <a:cs typeface="Calibri" pitchFamily="34" charset="-120"/>
+              </a:rPr>
+              <a:t>VÍ DỤ</a:t>
+            </a:r>
+          </a:p>
+        </p:txBody>
+      </p:sp>
+      <p:sp>
+        <p:nvSpPr>
+          <p:cNvPr id="9" name="Text 9"/>
+          <p:cNvSpPr/>
+          <p:nvPr/>
+        </p:nvSpPr>
+        <p:spPr>
+          <a:xfrm>
+            <a:off x="1021080" y="5257800"/>
+            <a:ext cx="10149840" cy="550000"/>
+          </a:xfrm>
+          <a:prstGeom prst="rect">
+            <a:avLst/>
+          </a:prstGeom>
+          <a:noFill/>
+          <a:ln/>
+        </p:spPr>
+        <p:txBody>
+          <a:bodyPr wrap="square" rtlCol="0" anchor="t">
+            <a:normAutofit/>
+          </a:bodyPr>
+          <a:lstStyle/>
+          <a:p>
+            <a:pPr algn="l" marL="0" indent="0">
+              <a:buNone/>
+            </a:pPr>
+            <a:r>
+              <a:rPr lang="vi-VN" sz="1200" i="1" dirty="0">
+                <a:solidFill>
+                  <a:srgbClr val="5B6B62"/>
+                </a:solidFill>
+                <a:latin typeface="Calibri" pitchFamily="34" charset="0"/>
+                <a:ea typeface="Calibri" pitchFamily="34" charset="-122"/>
+                <a:cs typeface="Calibri" pitchFamily="34" charset="-120"/>
+              </a:rPr>
+              <a:t>Một tour tham quan trung tâm bằng xe buýt điện hoặc buýt đường sông trên sông Sài Gòn giúp giảm khí thải so với việc mỗi nhóm khách thuê riêng một xe ô tô.</a:t>
+            </a:r>
+          </a:p>
+        </p:txBody>
+      </p:sp>
+    </p:spTree>
+  </p:cSld>
+  <p:clrMapOvr>
+    <a:masterClrMapping/>
+  </p:clrMapOvr>
+</p:sld>
 </file>
 
 <file path=ppt/slides/slide5.xml><?xml version="1.0" encoding="utf-8"?>
@@ -2186,8 +3867,228 @@
 </p:sld>
 </file>
 
-<file path=ppt/slides/slide7.xml><?xml version="1.0" encoding="UTF-8" standalone="yes"?>
-<p:sld xmlns:a="http://schemas.openxmlformats.org/drawingml/2006/main" xmlns:r="http://schemas.openxmlformats.org/officeDocument/2006/relationships" xmlns:p="http://schemas.openxmlformats.org/presentationml/2006/main"><p:cSld name="Thuận lợi & thách thức ở TP.HCM"><p:bg><p:bgPr><a:solidFill><a:srgbClr val="FAF8F2"/></a:solidFill><a:effectLst/></p:bgPr></p:bg><p:spTree><p:nvGrpSpPr><p:cNvPr id="1" name=""/><p:cNvGrpSpPr/><p:nvPr/></p:nvGrpSpPr><p:grpSpPr><a:xfrm><a:off x="0" y="0"/><a:ext cx="0" cy="0"/><a:chOff x="0" y="0"/><a:chExt cx="0" cy="0"/></a:xfrm></p:grpSpPr><p:sp><p:nvSpPr><p:cNvPr id="2" name="Shape 2"/><p:cNvSpPr/><p:nvPr/></p:nvSpPr><p:spPr><a:xfrm><a:off x="0" y="0"/><a:ext cx="12192000" cy="1143000"/></a:xfrm><a:prstGeom prst="rect"><a:avLst/></a:prstGeom><a:solidFill><a:srgbClr val="0E3B2E"/></a:solidFill><a:ln/></p:spPr><p:txBody><a:bodyPr/><a:lstStyle/><a:p><a:pPr><a:buNone/></a:pPr><a:endParaRPr lang="vi-VN"/></a:p></p:txBody></p:sp><p:sp><p:nvSpPr><p:cNvPr id="3" name="Text 3"/><p:cNvSpPr/><p:nvPr/></p:nvSpPr><p:spPr><a:xfrm><a:off x="838200" y="228600"/><a:ext cx="1000000" cy="500000"/></a:xfrm><a:prstGeom prst="rect"><a:avLst/></a:prstGeom><a:noFill/><a:ln/></p:spPr><p:txBody><a:bodyPr wrap="square" rtlCol="0" anchor="t"><a:normAutofit/></a:bodyPr><a:lstStyle/><a:p><a:pPr algn="l" marL="0" indent="0"><a:buNone/></a:pPr><a:r><a:rPr lang="vi-VN" sz="2400" b="1" dirty="0"><a:solidFill><a:srgbClr val="D9A441"/></a:solidFill><a:latin typeface="Cambria" pitchFamily="34" charset="0"/><a:ea typeface="Cambria" pitchFamily="34" charset="-122"/><a:cs typeface="Cambria" pitchFamily="34" charset="-120"/></a:rPr><a:t>05</a:t></a:r></a:p></p:txBody></p:sp><p:sp><p:nvSpPr><p:cNvPr id="4" name="Text 4"/><p:cNvSpPr/><p:nvPr/></p:nvSpPr><p:spPr><a:xfrm><a:off x="1638300" y="274320"/><a:ext cx="9715500" cy="600000"/></a:xfrm><a:prstGeom prst="rect"><a:avLst/></a:prstGeom><a:noFill/><a:ln/></p:spPr><p:txBody><a:bodyPr wrap="square" rtlCol="0" anchor="t"><a:normAutofit/></a:bodyPr><a:lstStyle/><a:p><a:pPr algn="l" marL="0" indent="0"><a:buNone/></a:pPr><a:r><a:rPr lang="vi-VN" sz="2200" b="1" dirty="0"><a:solidFill><a:srgbClr val="FFFFFF"/></a:solidFill><a:latin typeface="Cambria" pitchFamily="34" charset="0"/><a:ea typeface="Cambria" pitchFamily="34" charset="-122"/><a:cs typeface="Cambria" pitchFamily="34" charset="-120"/></a:rPr><a:t>Thuận lợi &amp; thách thức ở TP.HCM</a:t></a:r></a:p></p:txBody></p:sp><p:sp><p:nvSpPr><p:cNvPr id="5" name="Text 5"/><p:cNvSpPr/><p:nvPr/></p:nvSpPr><p:spPr><a:xfrm><a:off x="838200" y="1524000"/><a:ext cx="10515600" cy="3200000"/></a:xfrm><a:prstGeom prst="rect"><a:avLst/></a:prstGeom><a:noFill/><a:ln/></p:spPr><p:txBody><a:bodyPr wrap="square" rtlCol="0" anchor="t"><a:normAutofit/></a:bodyPr><a:lstStyle/><a:p><a:pPr algn="l" marL="216000" indent="-216000"><a:buFont typeface="Arial" pitchFamily="34" charset="0"/><a:buChar char="&#8226;"/></a:pPr><a:r><a:rPr lang="vi-VN" sz="1400" dirty="0"><a:solidFill><a:srgbClr val="1F2A24"/></a:solidFill><a:latin typeface="Calibri" pitchFamily="34" charset="0"/><a:ea typeface="Calibri" pitchFamily="34" charset="-122"/><a:cs typeface="Calibri" pitchFamily="34" charset="-120"/></a:rPr><a:t>Thuận lợi: hệ thống sông – kênh rạch, rừng ngập mặn, biển đảo, vùng nông nghiệp ven đô; lượng khách lớn; hạ tầng giao thông công cộng đang mở rộng (metro, buýt điện).</a:t></a:r></a:p><a:p><a:pPr algn="l" marL="216000" indent="-216000"><a:spcBef><a:spcPts val="900"/></a:spcBef><a:buFont typeface="Arial" pitchFamily="34" charset="0"/><a:buChar char="&#8226;"/></a:pPr><a:r><a:rPr lang="vi-VN" sz="1400" dirty="0"><a:solidFill><a:srgbClr val="1F2A24"/></a:solidFill><a:latin typeface="Calibri" pitchFamily="34" charset="0"/><a:ea typeface="Calibri" pitchFamily="34" charset="-122"/><a:cs typeface="Calibri" pitchFamily="34" charset="-120"/></a:rPr><a:t>Thách thức: ô nhiễm không khí – nguồn nước, ùn tắc, rác thải; chi phí đầu tư công nghệ xanh cao; nhận thức của một bộ phận du khách và doanh nghiệp còn hạn chế.</a:t></a:r></a:p><a:p><a:pPr algn="l" marL="216000" indent="-216000"><a:spcBef><a:spcPts val="900"/></a:spcBef><a:buFont typeface="Arial" pitchFamily="34" charset="0"/><a:buChar char="&#8226;"/></a:pPr><a:r><a:rPr lang="vi-VN" sz="1400" dirty="0"><a:solidFill><a:srgbClr val="1F2A24"/></a:solidFill><a:latin typeface="Calibri" pitchFamily="34" charset="0"/><a:ea typeface="Calibri" pitchFamily="34" charset="-122"/><a:cs typeface="Calibri" pitchFamily="34" charset="-120"/></a:rPr><a:t>Cần sự phối hợp giữa chính quyền – doanh nghiệp – cộng đồng – du khách.</a:t></a:r></a:p></p:txBody></p:sp></p:spTree></p:cSld><p:clrMapOvr><a:masterClrMapping/></p:clrMapOvr></p:sld>
+<file path=ppt/slides/slide7.xml><?xml version="1.0" encoding="utf-8"?>
+<p:sld xmlns:a="http://schemas.openxmlformats.org/drawingml/2006/main" xmlns:r="http://schemas.openxmlformats.org/officeDocument/2006/relationships" xmlns:p="http://schemas.openxmlformats.org/presentationml/2006/main">
+  <p:cSld name="Thuận lợi &amp; thách thức ở TP.HCM">
+    <p:bg>
+      <p:bgPr>
+        <a:solidFill>
+          <a:srgbClr val="FAF8F2"/>
+        </a:solidFill>
+        <a:effectLst/>
+      </p:bgPr>
+    </p:bg>
+    <p:spTree>
+      <p:nvGrpSpPr>
+        <p:cNvPr id="1" name=""/>
+        <p:cNvGrpSpPr/>
+        <p:nvPr/>
+      </p:nvGrpSpPr>
+      <p:grpSpPr>
+        <a:xfrm>
+          <a:off x="0" y="0"/>
+          <a:ext cx="0" cy="0"/>
+          <a:chOff x="0" y="0"/>
+          <a:chExt cx="0" cy="0"/>
+        </a:xfrm>
+      </p:grpSpPr>
+      <p:sp>
+        <p:nvSpPr>
+          <p:cNvPr id="2" name="Shape 2"/>
+          <p:cNvSpPr/>
+          <p:nvPr/>
+        </p:nvSpPr>
+        <p:spPr>
+          <a:xfrm>
+            <a:off x="0" y="0"/>
+            <a:ext cx="12192000" cy="1143000"/>
+          </a:xfrm>
+          <a:prstGeom prst="rect">
+            <a:avLst/>
+          </a:prstGeom>
+          <a:solidFill>
+            <a:srgbClr val="0E3B2E"/>
+          </a:solidFill>
+          <a:ln/>
+        </p:spPr>
+        <p:txBody>
+          <a:bodyPr/>
+          <a:lstStyle/>
+          <a:p>
+            <a:pPr>
+              <a:buNone/>
+            </a:pPr>
+            <a:endParaRPr lang="vi-VN"/>
+          </a:p>
+        </p:txBody>
+      </p:sp>
+      <p:sp>
+        <p:nvSpPr>
+          <p:cNvPr id="3" name="Text 3"/>
+          <p:cNvSpPr/>
+          <p:nvPr/>
+        </p:nvSpPr>
+        <p:spPr>
+          <a:xfrm>
+            <a:off x="838200" y="228600"/>
+            <a:ext cx="1000000" cy="500000"/>
+          </a:xfrm>
+          <a:prstGeom prst="rect">
+            <a:avLst/>
+          </a:prstGeom>
+          <a:noFill/>
+          <a:ln/>
+        </p:spPr>
+        <p:txBody>
+          <a:bodyPr wrap="square" rtlCol="0" anchor="t">
+            <a:normAutofit/>
+          </a:bodyPr>
+          <a:lstStyle/>
+          <a:p>
+            <a:pPr algn="l" marL="0" indent="0">
+              <a:buNone/>
+            </a:pPr>
+            <a:r>
+              <a:rPr lang="vi-VN" sz="2400" b="1" dirty="0">
+                <a:solidFill>
+                  <a:srgbClr val="D9A441"/>
+                </a:solidFill>
+                <a:latin typeface="Cambria" pitchFamily="34" charset="0"/>
+                <a:ea typeface="Cambria" pitchFamily="34" charset="-122"/>
+                <a:cs typeface="Cambria" pitchFamily="34" charset="-120"/>
+              </a:rPr>
+              <a:t>05</a:t>
+            </a:r>
+          </a:p>
+        </p:txBody>
+      </p:sp>
+      <p:sp>
+        <p:nvSpPr>
+          <p:cNvPr id="4" name="Text 4"/>
+          <p:cNvSpPr/>
+          <p:nvPr/>
+        </p:nvSpPr>
+        <p:spPr>
+          <a:xfrm>
+            <a:off x="1638300" y="274320"/>
+            <a:ext cx="9715500" cy="600000"/>
+          </a:xfrm>
+          <a:prstGeom prst="rect">
+            <a:avLst/>
+          </a:prstGeom>
+          <a:noFill/>
+          <a:ln/>
+        </p:spPr>
+        <p:txBody>
+          <a:bodyPr wrap="square" rtlCol="0" anchor="t">
+            <a:normAutofit/>
+          </a:bodyPr>
+          <a:lstStyle/>
+          <a:p>
+            <a:pPr algn="l" marL="0" indent="0">
+              <a:buNone/>
+            </a:pPr>
+            <a:r>
+              <a:rPr lang="vi-VN" sz="2200" b="1" dirty="0">
+                <a:solidFill>
+                  <a:srgbClr val="FFFFFF"/>
+                </a:solidFill>
+                <a:latin typeface="Cambria" pitchFamily="34" charset="0"/>
+                <a:ea typeface="Cambria" pitchFamily="34" charset="-122"/>
+                <a:cs typeface="Cambria" pitchFamily="34" charset="-120"/>
+              </a:rPr>
+              <a:t>Thuận lợi &amp; thách thức ở TP.HCM</a:t>
+            </a:r>
+          </a:p>
+        </p:txBody>
+      </p:sp>
+      <p:sp>
+        <p:nvSpPr>
+          <p:cNvPr id="5" name="Text 5"/>
+          <p:cNvSpPr/>
+          <p:nvPr/>
+        </p:nvSpPr>
+        <p:spPr>
+          <a:xfrm>
+            <a:off x="838200" y="1524000"/>
+            <a:ext cx="10515600" cy="3200000"/>
+          </a:xfrm>
+          <a:prstGeom prst="rect">
+            <a:avLst/>
+          </a:prstGeom>
+          <a:noFill/>
+          <a:ln/>
+        </p:spPr>
+        <p:txBody>
+          <a:bodyPr wrap="square" rtlCol="0" anchor="t">
+            <a:normAutofit/>
+          </a:bodyPr>
+          <a:lstStyle/>
+          <a:p>
+            <a:pPr algn="l" marL="216000" indent="-216000">
+              <a:buFont typeface="Arial" pitchFamily="34" charset="0"/>
+              <a:buChar char="•"/>
+            </a:pPr>
+            <a:r>
+              <a:rPr lang="vi-VN" sz="1400" dirty="0">
+                <a:solidFill>
+                  <a:srgbClr val="1F2A24"/>
+                </a:solidFill>
+                <a:latin typeface="Calibri" pitchFamily="34" charset="0"/>
+                <a:ea typeface="Calibri" pitchFamily="34" charset="-122"/>
+                <a:cs typeface="Calibri" pitchFamily="34" charset="-120"/>
+              </a:rPr>
+              <a:t>Thuận lợi: hệ thống sông – kênh rạch, rừng ngập mặn, biển đảo, vùng nông nghiệp ven đô; lượng khách lớn; hạ tầng giao thông công cộng đang mở rộng (metro, buýt điện).</a:t>
+            </a:r>
+          </a:p>
+          <a:p>
+            <a:pPr algn="l" marL="216000" indent="-216000">
+              <a:spcBef>
+                <a:spcPts val="900"/>
+              </a:spcBef>
+              <a:buFont typeface="Arial" pitchFamily="34" charset="0"/>
+              <a:buChar char="•"/>
+            </a:pPr>
+            <a:r>
+              <a:rPr lang="vi-VN" sz="1400" dirty="0">
+                <a:solidFill>
+                  <a:srgbClr val="1F2A24"/>
+                </a:solidFill>
+                <a:latin typeface="Calibri" pitchFamily="34" charset="0"/>
+                <a:ea typeface="Calibri" pitchFamily="34" charset="-122"/>
+                <a:cs typeface="Calibri" pitchFamily="34" charset="-120"/>
+              </a:rPr>
+              <a:t>Thách thức: ô nhiễm không khí – nguồn nước, ùn tắc, rác thải; chi phí đầu tư công nghệ xanh cao; nhận thức của một bộ phận du khách và doanh nghiệp còn hạn chế.</a:t>
+            </a:r>
+          </a:p>
+          <a:p>
+            <a:pPr algn="l" marL="216000" indent="-216000">
+              <a:spcBef>
+                <a:spcPts val="900"/>
+              </a:spcBef>
+              <a:buFont typeface="Arial" pitchFamily="34" charset="0"/>
+              <a:buChar char="•"/>
+            </a:pPr>
+            <a:r>
+              <a:rPr lang="vi-VN" sz="1400" dirty="0">
+                <a:solidFill>
+                  <a:srgbClr val="1F2A24"/>
+                </a:solidFill>
+                <a:latin typeface="Calibri" pitchFamily="34" charset="0"/>
+                <a:ea typeface="Calibri" pitchFamily="34" charset="-122"/>
+                <a:cs typeface="Calibri" pitchFamily="34" charset="-120"/>
+              </a:rPr>
+              <a:t>Cần sự phối hợp giữa chính quyền – doanh nghiệp – cộng đồng – du khách.</a:t>
+            </a:r>
+          </a:p>
+        </p:txBody>
+      </p:sp>
+    </p:spTree>
+  </p:cSld>
+  <p:clrMapOvr>
+    <a:masterClrMapping/>
+  </p:clrMapOvr>
+</p:sld>
 </file>
 
 <file path=ppt/slides/slide8.xml><?xml version="1.0" encoding="utf-8"?>

</xml_diff>